<commit_message>
Update configuration examples and GUI
</commit_message>
<xml_diff>
--- a/ConfigExamples.pptx
+++ b/ConfigExamples.pptx
@@ -273,7 +273,7 @@
           <a:p>
             <a:fld id="{E23D921C-80E9-4813-9630-6B31BC7B77DE}" type="datetimeFigureOut">
               <a:rPr lang="he-IL" smtClean="0"/>
-              <a:t>ד'/תשרי/תשפ"ז</a:t>
+              <a:t>י'/תשרי/תשפ"ז</a:t>
             </a:fld>
             <a:endParaRPr lang="he-IL"/>
           </a:p>
@@ -473,7 +473,7 @@
           <a:p>
             <a:fld id="{E23D921C-80E9-4813-9630-6B31BC7B77DE}" type="datetimeFigureOut">
               <a:rPr lang="he-IL" smtClean="0"/>
-              <a:t>ד'/תשרי/תשפ"ז</a:t>
+              <a:t>י'/תשרי/תשפ"ז</a:t>
             </a:fld>
             <a:endParaRPr lang="he-IL"/>
           </a:p>
@@ -683,7 +683,7 @@
           <a:p>
             <a:fld id="{E23D921C-80E9-4813-9630-6B31BC7B77DE}" type="datetimeFigureOut">
               <a:rPr lang="he-IL" smtClean="0"/>
-              <a:t>ד'/תשרי/תשפ"ז</a:t>
+              <a:t>י'/תשרי/תשפ"ז</a:t>
             </a:fld>
             <a:endParaRPr lang="he-IL"/>
           </a:p>
@@ -883,7 +883,7 @@
           <a:p>
             <a:fld id="{E23D921C-80E9-4813-9630-6B31BC7B77DE}" type="datetimeFigureOut">
               <a:rPr lang="he-IL" smtClean="0"/>
-              <a:t>ד'/תשרי/תשפ"ז</a:t>
+              <a:t>י'/תשרי/תשפ"ז</a:t>
             </a:fld>
             <a:endParaRPr lang="he-IL"/>
           </a:p>
@@ -1159,7 +1159,7 @@
           <a:p>
             <a:fld id="{E23D921C-80E9-4813-9630-6B31BC7B77DE}" type="datetimeFigureOut">
               <a:rPr lang="he-IL" smtClean="0"/>
-              <a:t>ד'/תשרי/תשפ"ז</a:t>
+              <a:t>י'/תשרי/תשפ"ז</a:t>
             </a:fld>
             <a:endParaRPr lang="he-IL"/>
           </a:p>
@@ -1427,7 +1427,7 @@
           <a:p>
             <a:fld id="{E23D921C-80E9-4813-9630-6B31BC7B77DE}" type="datetimeFigureOut">
               <a:rPr lang="he-IL" smtClean="0"/>
-              <a:t>ד'/תשרי/תשפ"ז</a:t>
+              <a:t>י'/תשרי/תשפ"ז</a:t>
             </a:fld>
             <a:endParaRPr lang="he-IL"/>
           </a:p>
@@ -1842,7 +1842,7 @@
           <a:p>
             <a:fld id="{E23D921C-80E9-4813-9630-6B31BC7B77DE}" type="datetimeFigureOut">
               <a:rPr lang="he-IL" smtClean="0"/>
-              <a:t>ד'/תשרי/תשפ"ז</a:t>
+              <a:t>י'/תשרי/תשפ"ז</a:t>
             </a:fld>
             <a:endParaRPr lang="he-IL"/>
           </a:p>
@@ -1984,7 +1984,7 @@
           <a:p>
             <a:fld id="{E23D921C-80E9-4813-9630-6B31BC7B77DE}" type="datetimeFigureOut">
               <a:rPr lang="he-IL" smtClean="0"/>
-              <a:t>ד'/תשרי/תשפ"ז</a:t>
+              <a:t>י'/תשרי/תשפ"ז</a:t>
             </a:fld>
             <a:endParaRPr lang="he-IL"/>
           </a:p>
@@ -2097,7 +2097,7 @@
           <a:p>
             <a:fld id="{E23D921C-80E9-4813-9630-6B31BC7B77DE}" type="datetimeFigureOut">
               <a:rPr lang="he-IL" smtClean="0"/>
-              <a:t>ד'/תשרי/תשפ"ז</a:t>
+              <a:t>י'/תשרי/תשפ"ז</a:t>
             </a:fld>
             <a:endParaRPr lang="he-IL"/>
           </a:p>
@@ -2410,7 +2410,7 @@
           <a:p>
             <a:fld id="{E23D921C-80E9-4813-9630-6B31BC7B77DE}" type="datetimeFigureOut">
               <a:rPr lang="he-IL" smtClean="0"/>
-              <a:t>ד'/תשרי/תשפ"ז</a:t>
+              <a:t>י'/תשרי/תשפ"ז</a:t>
             </a:fld>
             <a:endParaRPr lang="he-IL"/>
           </a:p>
@@ -2699,7 +2699,7 @@
           <a:p>
             <a:fld id="{E23D921C-80E9-4813-9630-6B31BC7B77DE}" type="datetimeFigureOut">
               <a:rPr lang="he-IL" smtClean="0"/>
-              <a:t>ד'/תשרי/תשפ"ז</a:t>
+              <a:t>י'/תשרי/תשפ"ז</a:t>
             </a:fld>
             <a:endParaRPr lang="he-IL"/>
           </a:p>
@@ -2942,7 +2942,7 @@
           <a:p>
             <a:fld id="{E23D921C-80E9-4813-9630-6B31BC7B77DE}" type="datetimeFigureOut">
               <a:rPr lang="he-IL" smtClean="0"/>
-              <a:t>ד'/תשרי/תשפ"ז</a:t>
+              <a:t>י'/תשרי/תשפ"ז</a:t>
             </a:fld>
             <a:endParaRPr lang="he-IL"/>
           </a:p>
@@ -3425,6 +3425,36 @@
           <a:chExt cx="0" cy="0"/>
         </a:xfrm>
       </p:grpSpPr>
+      <p:pic>
+        <p:nvPicPr>
+          <p:cNvPr id="5" name="Picture 4">
+            <a:extLst>
+              <a:ext uri="{FF2B5EF4-FFF2-40B4-BE49-F238E27FC236}">
+                <a16:creationId xmlns:a16="http://schemas.microsoft.com/office/drawing/2014/main" id="{3C8475EB-5D48-DE21-8106-B215EA72B6DC}"/>
+              </a:ext>
+            </a:extLst>
+          </p:cNvPr>
+          <p:cNvPicPr>
+            <a:picLocks noChangeAspect="1"/>
+          </p:cNvPicPr>
+          <p:nvPr/>
+        </p:nvPicPr>
+        <p:blipFill>
+          <a:blip r:embed="rId2"/>
+          <a:stretch>
+            <a:fillRect/>
+          </a:stretch>
+        </p:blipFill>
+        <p:spPr>
+          <a:xfrm>
+            <a:off x="163235" y="144270"/>
+            <a:ext cx="10378641" cy="6463158"/>
+          </a:xfrm>
+          <a:prstGeom prst="rect">
+            <a:avLst/>
+          </a:prstGeom>
+        </p:spPr>
+      </p:pic>
     </p:spTree>
     <p:extLst>
       <p:ext uri="{BB962C8B-B14F-4D97-AF65-F5344CB8AC3E}">

</xml_diff>

<commit_message>
Update ConfigExamples presentation with new content
</commit_message>
<xml_diff>
--- a/ConfigExamples.pptx
+++ b/ConfigExamples.pptx
@@ -3491,6 +3491,36 @@
           <a:chExt cx="0" cy="0"/>
         </a:xfrm>
       </p:grpSpPr>
+      <p:pic>
+        <p:nvPicPr>
+          <p:cNvPr id="3" name="Picture 2">
+            <a:extLst>
+              <a:ext uri="{FF2B5EF4-FFF2-40B4-BE49-F238E27FC236}">
+                <a16:creationId xmlns:a16="http://schemas.microsoft.com/office/drawing/2014/main" id="{BCC8F774-303E-F1CC-EE62-22ABC7DDE3BC}"/>
+              </a:ext>
+            </a:extLst>
+          </p:cNvPr>
+          <p:cNvPicPr>
+            <a:picLocks noChangeAspect="1"/>
+          </p:cNvPicPr>
+          <p:nvPr/>
+        </p:nvPicPr>
+        <p:blipFill>
+          <a:blip r:embed="rId2"/>
+          <a:stretch>
+            <a:fillRect/>
+          </a:stretch>
+        </p:blipFill>
+        <p:spPr>
+          <a:xfrm>
+            <a:off x="282979" y="0"/>
+            <a:ext cx="11884848" cy="6571622"/>
+          </a:xfrm>
+          <a:prstGeom prst="rect">
+            <a:avLst/>
+          </a:prstGeom>
+        </p:spPr>
+      </p:pic>
     </p:spTree>
     <p:extLst>
       <p:ext uri="{BB962C8B-B14F-4D97-AF65-F5344CB8AC3E}">
@@ -3527,6 +3557,36 @@
           <a:chExt cx="0" cy="0"/>
         </a:xfrm>
       </p:grpSpPr>
+      <p:pic>
+        <p:nvPicPr>
+          <p:cNvPr id="3" name="Picture 2">
+            <a:extLst>
+              <a:ext uri="{FF2B5EF4-FFF2-40B4-BE49-F238E27FC236}">
+                <a16:creationId xmlns:a16="http://schemas.microsoft.com/office/drawing/2014/main" id="{3376E5BC-F3F0-65B5-02F9-7736F3DAACAA}"/>
+              </a:ext>
+            </a:extLst>
+          </p:cNvPr>
+          <p:cNvPicPr>
+            <a:picLocks noChangeAspect="1"/>
+          </p:cNvPicPr>
+          <p:nvPr/>
+        </p:nvPicPr>
+        <p:blipFill>
+          <a:blip r:embed="rId2"/>
+          <a:stretch>
+            <a:fillRect/>
+          </a:stretch>
+        </p:blipFill>
+        <p:spPr>
+          <a:xfrm>
+            <a:off x="105240" y="1"/>
+            <a:ext cx="11859293" cy="6400800"/>
+          </a:xfrm>
+          <a:prstGeom prst="rect">
+            <a:avLst/>
+          </a:prstGeom>
+        </p:spPr>
+      </p:pic>
     </p:spTree>
     <p:extLst>
       <p:ext uri="{BB962C8B-B14F-4D97-AF65-F5344CB8AC3E}">

</xml_diff>

<commit_message>
Enhance error handling in RodGUI by including traceback information and clean up mainRunGUI.py
</commit_message>
<xml_diff>
--- a/ConfigExamples.pptx
+++ b/ConfigExamples.pptx
@@ -8,16 +8,14 @@
     <p:sldId id="256" r:id="rId2"/>
     <p:sldId id="257" r:id="rId3"/>
     <p:sldId id="258" r:id="rId4"/>
-    <p:sldId id="259" r:id="rId5"/>
-    <p:sldId id="260" r:id="rId6"/>
-    <p:sldId id="261" r:id="rId7"/>
-    <p:sldId id="262" r:id="rId8"/>
-    <p:sldId id="263" r:id="rId9"/>
-    <p:sldId id="264" r:id="rId10"/>
-    <p:sldId id="265" r:id="rId11"/>
-    <p:sldId id="266" r:id="rId12"/>
-    <p:sldId id="267" r:id="rId13"/>
-    <p:sldId id="268" r:id="rId14"/>
+    <p:sldId id="260" r:id="rId5"/>
+    <p:sldId id="261" r:id="rId6"/>
+    <p:sldId id="262" r:id="rId7"/>
+    <p:sldId id="263" r:id="rId8"/>
+    <p:sldId id="265" r:id="rId9"/>
+    <p:sldId id="266" r:id="rId10"/>
+    <p:sldId id="267" r:id="rId11"/>
+    <p:sldId id="268" r:id="rId12"/>
   </p:sldIdLst>
   <p:sldSz cx="12192000" cy="6858000"/>
   <p:notesSz cx="6858000" cy="9144000"/>
@@ -3410,138 +3408,6 @@
         <p:cNvPr id="1" name="">
           <a:extLst>
             <a:ext uri="{FF2B5EF4-FFF2-40B4-BE49-F238E27FC236}">
-              <a16:creationId xmlns:a16="http://schemas.microsoft.com/office/drawing/2014/main" id="{C1E411DA-3A6D-3C49-71F9-A2297B949CBA}"/>
-            </a:ext>
-          </a:extLst>
-        </p:cNvPr>
-        <p:cNvGrpSpPr/>
-        <p:nvPr/>
-      </p:nvGrpSpPr>
-      <p:grpSpPr>
-        <a:xfrm>
-          <a:off x="0" y="0"/>
-          <a:ext cx="0" cy="0"/>
-          <a:chOff x="0" y="0"/>
-          <a:chExt cx="0" cy="0"/>
-        </a:xfrm>
-      </p:grpSpPr>
-      <p:pic>
-        <p:nvPicPr>
-          <p:cNvPr id="5" name="Picture 4">
-            <a:extLst>
-              <a:ext uri="{FF2B5EF4-FFF2-40B4-BE49-F238E27FC236}">
-                <a16:creationId xmlns:a16="http://schemas.microsoft.com/office/drawing/2014/main" id="{3C8475EB-5D48-DE21-8106-B215EA72B6DC}"/>
-              </a:ext>
-            </a:extLst>
-          </p:cNvPr>
-          <p:cNvPicPr>
-            <a:picLocks noChangeAspect="1"/>
-          </p:cNvPicPr>
-          <p:nvPr/>
-        </p:nvPicPr>
-        <p:blipFill>
-          <a:blip r:embed="rId2"/>
-          <a:stretch>
-            <a:fillRect/>
-          </a:stretch>
-        </p:blipFill>
-        <p:spPr>
-          <a:xfrm>
-            <a:off x="163235" y="144270"/>
-            <a:ext cx="10378641" cy="6463158"/>
-          </a:xfrm>
-          <a:prstGeom prst="rect">
-            <a:avLst/>
-          </a:prstGeom>
-        </p:spPr>
-      </p:pic>
-    </p:spTree>
-    <p:extLst>
-      <p:ext uri="{BB962C8B-B14F-4D97-AF65-F5344CB8AC3E}">
-        <p14:creationId xmlns:p14="http://schemas.microsoft.com/office/powerpoint/2010/main" val="3000770512"/>
-      </p:ext>
-    </p:extLst>
-  </p:cSld>
-  <p:clrMapOvr>
-    <a:masterClrMapping/>
-  </p:clrMapOvr>
-</p:sld>
-</file>
-
-<file path=ppt/slides/slide11.xml><?xml version="1.0" encoding="utf-8"?>
-<p:sld xmlns:a="http://schemas.openxmlformats.org/drawingml/2006/main" xmlns:r="http://schemas.openxmlformats.org/officeDocument/2006/relationships" xmlns:p="http://schemas.openxmlformats.org/presentationml/2006/main">
-  <p:cSld>
-    <p:spTree>
-      <p:nvGrpSpPr>
-        <p:cNvPr id="1" name="">
-          <a:extLst>
-            <a:ext uri="{FF2B5EF4-FFF2-40B4-BE49-F238E27FC236}">
-              <a16:creationId xmlns:a16="http://schemas.microsoft.com/office/drawing/2014/main" id="{406EDA05-9A64-9D13-8800-B38D300BF952}"/>
-            </a:ext>
-          </a:extLst>
-        </p:cNvPr>
-        <p:cNvGrpSpPr/>
-        <p:nvPr/>
-      </p:nvGrpSpPr>
-      <p:grpSpPr>
-        <a:xfrm>
-          <a:off x="0" y="0"/>
-          <a:ext cx="0" cy="0"/>
-          <a:chOff x="0" y="0"/>
-          <a:chExt cx="0" cy="0"/>
-        </a:xfrm>
-      </p:grpSpPr>
-      <p:pic>
-        <p:nvPicPr>
-          <p:cNvPr id="3" name="Picture 2">
-            <a:extLst>
-              <a:ext uri="{FF2B5EF4-FFF2-40B4-BE49-F238E27FC236}">
-                <a16:creationId xmlns:a16="http://schemas.microsoft.com/office/drawing/2014/main" id="{BCC8F774-303E-F1CC-EE62-22ABC7DDE3BC}"/>
-              </a:ext>
-            </a:extLst>
-          </p:cNvPr>
-          <p:cNvPicPr>
-            <a:picLocks noChangeAspect="1"/>
-          </p:cNvPicPr>
-          <p:nvPr/>
-        </p:nvPicPr>
-        <p:blipFill>
-          <a:blip r:embed="rId2"/>
-          <a:stretch>
-            <a:fillRect/>
-          </a:stretch>
-        </p:blipFill>
-        <p:spPr>
-          <a:xfrm>
-            <a:off x="282979" y="0"/>
-            <a:ext cx="11884848" cy="6571622"/>
-          </a:xfrm>
-          <a:prstGeom prst="rect">
-            <a:avLst/>
-          </a:prstGeom>
-        </p:spPr>
-      </p:pic>
-    </p:spTree>
-    <p:extLst>
-      <p:ext uri="{BB962C8B-B14F-4D97-AF65-F5344CB8AC3E}">
-        <p14:creationId xmlns:p14="http://schemas.microsoft.com/office/powerpoint/2010/main" val="902846263"/>
-      </p:ext>
-    </p:extLst>
-  </p:cSld>
-  <p:clrMapOvr>
-    <a:masterClrMapping/>
-  </p:clrMapOvr>
-</p:sld>
-</file>
-
-<file path=ppt/slides/slide12.xml><?xml version="1.0" encoding="utf-8"?>
-<p:sld xmlns:a="http://schemas.openxmlformats.org/drawingml/2006/main" xmlns:r="http://schemas.openxmlformats.org/officeDocument/2006/relationships" xmlns:p="http://schemas.openxmlformats.org/presentationml/2006/main">
-  <p:cSld>
-    <p:spTree>
-      <p:nvGrpSpPr>
-        <p:cNvPr id="1" name="">
-          <a:extLst>
-            <a:ext uri="{FF2B5EF4-FFF2-40B4-BE49-F238E27FC236}">
               <a16:creationId xmlns:a16="http://schemas.microsoft.com/office/drawing/2014/main" id="{3A0475EB-9BA9-13FA-1856-4692074F9A19}"/>
             </a:ext>
           </a:extLst>
@@ -3600,7 +3466,7 @@
 </p:sld>
 </file>
 
-<file path=ppt/slides/slide13.xml><?xml version="1.0" encoding="utf-8"?>
+<file path=ppt/slides/slide11.xml><?xml version="1.0" encoding="utf-8"?>
 <p:sld xmlns:a="http://schemas.openxmlformats.org/drawingml/2006/main" xmlns:r="http://schemas.openxmlformats.org/officeDocument/2006/relationships" xmlns:p="http://schemas.openxmlformats.org/presentationml/2006/main">
   <p:cSld>
     <p:spTree>
@@ -3623,6 +3489,66 @@
           <a:chExt cx="0" cy="0"/>
         </a:xfrm>
       </p:grpSpPr>
+      <p:pic>
+        <p:nvPicPr>
+          <p:cNvPr id="3" name="Picture 2">
+            <a:extLst>
+              <a:ext uri="{FF2B5EF4-FFF2-40B4-BE49-F238E27FC236}">
+                <a16:creationId xmlns:a16="http://schemas.microsoft.com/office/drawing/2014/main" id="{A30BE5D4-8E53-6823-CBD4-C7E3390F3E32}"/>
+              </a:ext>
+            </a:extLst>
+          </p:cNvPr>
+          <p:cNvPicPr>
+            <a:picLocks noChangeAspect="1"/>
+          </p:cNvPicPr>
+          <p:nvPr/>
+        </p:nvPicPr>
+        <p:blipFill>
+          <a:blip r:embed="rId2"/>
+          <a:stretch>
+            <a:fillRect/>
+          </a:stretch>
+        </p:blipFill>
+        <p:spPr>
+          <a:xfrm>
+            <a:off x="2943152" y="860839"/>
+            <a:ext cx="9248848" cy="5136321"/>
+          </a:xfrm>
+          <a:prstGeom prst="rect">
+            <a:avLst/>
+          </a:prstGeom>
+        </p:spPr>
+      </p:pic>
+      <p:pic>
+        <p:nvPicPr>
+          <p:cNvPr id="5" name="Picture 4">
+            <a:extLst>
+              <a:ext uri="{FF2B5EF4-FFF2-40B4-BE49-F238E27FC236}">
+                <a16:creationId xmlns:a16="http://schemas.microsoft.com/office/drawing/2014/main" id="{4A318AA8-A387-C61E-36D5-705EBB7804AB}"/>
+              </a:ext>
+            </a:extLst>
+          </p:cNvPr>
+          <p:cNvPicPr>
+            <a:picLocks noChangeAspect="1"/>
+          </p:cNvPicPr>
+          <p:nvPr/>
+        </p:nvPicPr>
+        <p:blipFill>
+          <a:blip r:embed="rId3"/>
+          <a:stretch>
+            <a:fillRect/>
+          </a:stretch>
+        </p:blipFill>
+        <p:spPr>
+          <a:xfrm>
+            <a:off x="158673" y="672661"/>
+            <a:ext cx="2570783" cy="5512676"/>
+          </a:xfrm>
+          <a:prstGeom prst="rect">
+            <a:avLst/>
+          </a:prstGeom>
+        </p:spPr>
+      </p:pic>
     </p:spTree>
     <p:extLst>
       <p:ext uri="{BB962C8B-B14F-4D97-AF65-F5344CB8AC3E}">
@@ -3806,102 +3732,6 @@
         <p:cNvPr id="1" name="">
           <a:extLst>
             <a:ext uri="{FF2B5EF4-FFF2-40B4-BE49-F238E27FC236}">
-              <a16:creationId xmlns:a16="http://schemas.microsoft.com/office/drawing/2014/main" id="{B69E3E61-3D86-5816-9CD2-6BF75F8A9C84}"/>
-            </a:ext>
-          </a:extLst>
-        </p:cNvPr>
-        <p:cNvGrpSpPr/>
-        <p:nvPr/>
-      </p:nvGrpSpPr>
-      <p:grpSpPr>
-        <a:xfrm>
-          <a:off x="0" y="0"/>
-          <a:ext cx="0" cy="0"/>
-          <a:chOff x="0" y="0"/>
-          <a:chExt cx="0" cy="0"/>
-        </a:xfrm>
-      </p:grpSpPr>
-      <p:pic>
-        <p:nvPicPr>
-          <p:cNvPr id="5" name="Picture 4">
-            <a:extLst>
-              <a:ext uri="{FF2B5EF4-FFF2-40B4-BE49-F238E27FC236}">
-                <a16:creationId xmlns:a16="http://schemas.microsoft.com/office/drawing/2014/main" id="{C3CEBEF1-6101-4B37-8932-CC226AC97DF9}"/>
-              </a:ext>
-            </a:extLst>
-          </p:cNvPr>
-          <p:cNvPicPr>
-            <a:picLocks noChangeAspect="1"/>
-          </p:cNvPicPr>
-          <p:nvPr/>
-        </p:nvPicPr>
-        <p:blipFill>
-          <a:blip r:embed="rId2"/>
-          <a:stretch>
-            <a:fillRect/>
-          </a:stretch>
-        </p:blipFill>
-        <p:spPr>
-          <a:xfrm>
-            <a:off x="0" y="0"/>
-            <a:ext cx="8429297" cy="4391773"/>
-          </a:xfrm>
-          <a:prstGeom prst="rect">
-            <a:avLst/>
-          </a:prstGeom>
-        </p:spPr>
-      </p:pic>
-      <p:pic>
-        <p:nvPicPr>
-          <p:cNvPr id="7" name="Picture 6">
-            <a:extLst>
-              <a:ext uri="{FF2B5EF4-FFF2-40B4-BE49-F238E27FC236}">
-                <a16:creationId xmlns:a16="http://schemas.microsoft.com/office/drawing/2014/main" id="{9CCC7245-22B2-63B5-9063-0AE166814A5C}"/>
-              </a:ext>
-            </a:extLst>
-          </p:cNvPr>
-          <p:cNvPicPr>
-            <a:picLocks noChangeAspect="1"/>
-          </p:cNvPicPr>
-          <p:nvPr/>
-        </p:nvPicPr>
-        <p:blipFill>
-          <a:blip r:embed="rId3"/>
-          <a:stretch>
-            <a:fillRect/>
-          </a:stretch>
-        </p:blipFill>
-        <p:spPr>
-          <a:xfrm>
-            <a:off x="6096000" y="4321179"/>
-            <a:ext cx="6096000" cy="2536821"/>
-          </a:xfrm>
-          <a:prstGeom prst="rect">
-            <a:avLst/>
-          </a:prstGeom>
-        </p:spPr>
-      </p:pic>
-    </p:spTree>
-    <p:extLst>
-      <p:ext uri="{BB962C8B-B14F-4D97-AF65-F5344CB8AC3E}">
-        <p14:creationId xmlns:p14="http://schemas.microsoft.com/office/powerpoint/2010/main" val="890991205"/>
-      </p:ext>
-    </p:extLst>
-  </p:cSld>
-  <p:clrMapOvr>
-    <a:masterClrMapping/>
-  </p:clrMapOvr>
-</p:sld>
-</file>
-
-<file path=ppt/slides/slide5.xml><?xml version="1.0" encoding="utf-8"?>
-<p:sld xmlns:a="http://schemas.openxmlformats.org/drawingml/2006/main" xmlns:r="http://schemas.openxmlformats.org/officeDocument/2006/relationships" xmlns:p="http://schemas.openxmlformats.org/presentationml/2006/main">
-  <p:cSld>
-    <p:spTree>
-      <p:nvGrpSpPr>
-        <p:cNvPr id="1" name="">
-          <a:extLst>
-            <a:ext uri="{FF2B5EF4-FFF2-40B4-BE49-F238E27FC236}">
               <a16:creationId xmlns:a16="http://schemas.microsoft.com/office/drawing/2014/main" id="{8A2D66E7-8EDF-9A19-BC24-81818CC27009}"/>
             </a:ext>
           </a:extLst>
@@ -3960,7 +3790,7 @@
 </p:sld>
 </file>
 
-<file path=ppt/slides/slide6.xml><?xml version="1.0" encoding="utf-8"?>
+<file path=ppt/slides/slide5.xml><?xml version="1.0" encoding="utf-8"?>
 <p:sld xmlns:a="http://schemas.openxmlformats.org/drawingml/2006/main" xmlns:r="http://schemas.openxmlformats.org/officeDocument/2006/relationships" xmlns:p="http://schemas.openxmlformats.org/presentationml/2006/main">
   <p:cSld>
     <p:spTree>
@@ -4026,7 +3856,7 @@
 </p:sld>
 </file>
 
-<file path=ppt/slides/slide7.xml><?xml version="1.0" encoding="utf-8"?>
+<file path=ppt/slides/slide6.xml><?xml version="1.0" encoding="utf-8"?>
 <p:sld xmlns:a="http://schemas.openxmlformats.org/drawingml/2006/main" xmlns:r="http://schemas.openxmlformats.org/officeDocument/2006/relationships" xmlns:p="http://schemas.openxmlformats.org/presentationml/2006/main">
   <p:cSld>
     <p:spTree>
@@ -4092,7 +3922,7 @@
 </p:sld>
 </file>
 
-<file path=ppt/slides/slide8.xml><?xml version="1.0" encoding="utf-8"?>
+<file path=ppt/slides/slide7.xml><?xml version="1.0" encoding="utf-8"?>
 <p:sld xmlns:a="http://schemas.openxmlformats.org/drawingml/2006/main" xmlns:r="http://schemas.openxmlformats.org/officeDocument/2006/relationships" xmlns:p="http://schemas.openxmlformats.org/presentationml/2006/main">
   <p:cSld>
     <p:spTree>
@@ -4308,6 +4138,72 @@
 </p:sld>
 </file>
 
+<file path=ppt/slides/slide8.xml><?xml version="1.0" encoding="utf-8"?>
+<p:sld xmlns:a="http://schemas.openxmlformats.org/drawingml/2006/main" xmlns:r="http://schemas.openxmlformats.org/officeDocument/2006/relationships" xmlns:p="http://schemas.openxmlformats.org/presentationml/2006/main">
+  <p:cSld>
+    <p:spTree>
+      <p:nvGrpSpPr>
+        <p:cNvPr id="1" name="">
+          <a:extLst>
+            <a:ext uri="{FF2B5EF4-FFF2-40B4-BE49-F238E27FC236}">
+              <a16:creationId xmlns:a16="http://schemas.microsoft.com/office/drawing/2014/main" id="{C1E411DA-3A6D-3C49-71F9-A2297B949CBA}"/>
+            </a:ext>
+          </a:extLst>
+        </p:cNvPr>
+        <p:cNvGrpSpPr/>
+        <p:nvPr/>
+      </p:nvGrpSpPr>
+      <p:grpSpPr>
+        <a:xfrm>
+          <a:off x="0" y="0"/>
+          <a:ext cx="0" cy="0"/>
+          <a:chOff x="0" y="0"/>
+          <a:chExt cx="0" cy="0"/>
+        </a:xfrm>
+      </p:grpSpPr>
+      <p:pic>
+        <p:nvPicPr>
+          <p:cNvPr id="5" name="Picture 4">
+            <a:extLst>
+              <a:ext uri="{FF2B5EF4-FFF2-40B4-BE49-F238E27FC236}">
+                <a16:creationId xmlns:a16="http://schemas.microsoft.com/office/drawing/2014/main" id="{3C8475EB-5D48-DE21-8106-B215EA72B6DC}"/>
+              </a:ext>
+            </a:extLst>
+          </p:cNvPr>
+          <p:cNvPicPr>
+            <a:picLocks noChangeAspect="1"/>
+          </p:cNvPicPr>
+          <p:nvPr/>
+        </p:nvPicPr>
+        <p:blipFill>
+          <a:blip r:embed="rId2"/>
+          <a:stretch>
+            <a:fillRect/>
+          </a:stretch>
+        </p:blipFill>
+        <p:spPr>
+          <a:xfrm>
+            <a:off x="163235" y="144270"/>
+            <a:ext cx="10378641" cy="6463158"/>
+          </a:xfrm>
+          <a:prstGeom prst="rect">
+            <a:avLst/>
+          </a:prstGeom>
+        </p:spPr>
+      </p:pic>
+    </p:spTree>
+    <p:extLst>
+      <p:ext uri="{BB962C8B-B14F-4D97-AF65-F5344CB8AC3E}">
+        <p14:creationId xmlns:p14="http://schemas.microsoft.com/office/powerpoint/2010/main" val="3000770512"/>
+      </p:ext>
+    </p:extLst>
+  </p:cSld>
+  <p:clrMapOvr>
+    <a:masterClrMapping/>
+  </p:clrMapOvr>
+</p:sld>
+</file>
+
 <file path=ppt/slides/slide9.xml><?xml version="1.0" encoding="utf-8"?>
 <p:sld xmlns:a="http://schemas.openxmlformats.org/drawingml/2006/main" xmlns:r="http://schemas.openxmlformats.org/officeDocument/2006/relationships" xmlns:p="http://schemas.openxmlformats.org/presentationml/2006/main">
   <p:cSld>
@@ -4316,7 +4212,7 @@
         <p:cNvPr id="1" name="">
           <a:extLst>
             <a:ext uri="{FF2B5EF4-FFF2-40B4-BE49-F238E27FC236}">
-              <a16:creationId xmlns:a16="http://schemas.microsoft.com/office/drawing/2014/main" id="{060DBC43-15AA-BAD3-4E6A-48D140607FEA}"/>
+              <a16:creationId xmlns:a16="http://schemas.microsoft.com/office/drawing/2014/main" id="{406EDA05-9A64-9D13-8800-B38D300BF952}"/>
             </a:ext>
           </a:extLst>
         </p:cNvPr>
@@ -4336,7 +4232,7 @@
           <p:cNvPr id="3" name="Picture 2">
             <a:extLst>
               <a:ext uri="{FF2B5EF4-FFF2-40B4-BE49-F238E27FC236}">
-                <a16:creationId xmlns:a16="http://schemas.microsoft.com/office/drawing/2014/main" id="{E8B1F9A1-1E37-E1CE-6E0F-757DCCD7C163}"/>
+                <a16:creationId xmlns:a16="http://schemas.microsoft.com/office/drawing/2014/main" id="{BCC8F774-303E-F1CC-EE62-22ABC7DDE3BC}"/>
               </a:ext>
             </a:extLst>
           </p:cNvPr>
@@ -4353,8 +4249,8 @@
         </p:blipFill>
         <p:spPr>
           <a:xfrm>
-            <a:off x="945793" y="355957"/>
-            <a:ext cx="10300413" cy="1619987"/>
+            <a:off x="282979" y="0"/>
+            <a:ext cx="11884848" cy="6571622"/>
           </a:xfrm>
           <a:prstGeom prst="rect">
             <a:avLst/>
@@ -4364,7 +4260,7 @@
     </p:spTree>
     <p:extLst>
       <p:ext uri="{BB962C8B-B14F-4D97-AF65-F5344CB8AC3E}">
-        <p14:creationId xmlns:p14="http://schemas.microsoft.com/office/powerpoint/2010/main" val="1140800696"/>
+        <p14:creationId xmlns:p14="http://schemas.microsoft.com/office/powerpoint/2010/main" val="902846263"/>
       </p:ext>
     </p:extLst>
   </p:cSld>

</xml_diff>

<commit_message>
Add updated ConfigExamples presentation file
</commit_message>
<xml_diff>
--- a/ConfigExamples.pptx
+++ b/ConfigExamples.pptx
@@ -5,17 +5,14 @@
     <p:sldMasterId id="2147483648" r:id="rId1"/>
   </p:sldMasterIdLst>
   <p:sldIdLst>
-    <p:sldId id="256" r:id="rId2"/>
-    <p:sldId id="257" r:id="rId3"/>
-    <p:sldId id="258" r:id="rId4"/>
-    <p:sldId id="260" r:id="rId5"/>
-    <p:sldId id="261" r:id="rId6"/>
-    <p:sldId id="262" r:id="rId7"/>
-    <p:sldId id="263" r:id="rId8"/>
-    <p:sldId id="265" r:id="rId9"/>
-    <p:sldId id="266" r:id="rId10"/>
-    <p:sldId id="267" r:id="rId11"/>
-    <p:sldId id="268" r:id="rId12"/>
+    <p:sldId id="265" r:id="rId2"/>
+    <p:sldId id="266" r:id="rId3"/>
+    <p:sldId id="267" r:id="rId4"/>
+    <p:sldId id="271" r:id="rId5"/>
+    <p:sldId id="272" r:id="rId6"/>
+    <p:sldId id="268" r:id="rId7"/>
+    <p:sldId id="269" r:id="rId8"/>
+    <p:sldId id="270" r:id="rId9"/>
   </p:sldIdLst>
   <p:sldSz cx="12192000" cy="6858000"/>
   <p:notesSz cx="6858000" cy="9144000"/>
@@ -271,7 +268,7 @@
           <a:p>
             <a:fld id="{E23D921C-80E9-4813-9630-6B31BC7B77DE}" type="datetimeFigureOut">
               <a:rPr lang="he-IL" smtClean="0"/>
-              <a:t>י'/תשרי/תשפ"ז</a:t>
+              <a:t>י"א/תשרי/תשפ"ז</a:t>
             </a:fld>
             <a:endParaRPr lang="he-IL"/>
           </a:p>
@@ -471,7 +468,7 @@
           <a:p>
             <a:fld id="{E23D921C-80E9-4813-9630-6B31BC7B77DE}" type="datetimeFigureOut">
               <a:rPr lang="he-IL" smtClean="0"/>
-              <a:t>י'/תשרי/תשפ"ז</a:t>
+              <a:t>י"א/תשרי/תשפ"ז</a:t>
             </a:fld>
             <a:endParaRPr lang="he-IL"/>
           </a:p>
@@ -681,7 +678,7 @@
           <a:p>
             <a:fld id="{E23D921C-80E9-4813-9630-6B31BC7B77DE}" type="datetimeFigureOut">
               <a:rPr lang="he-IL" smtClean="0"/>
-              <a:t>י'/תשרי/תשפ"ז</a:t>
+              <a:t>י"א/תשרי/תשפ"ז</a:t>
             </a:fld>
             <a:endParaRPr lang="he-IL"/>
           </a:p>
@@ -881,7 +878,7 @@
           <a:p>
             <a:fld id="{E23D921C-80E9-4813-9630-6B31BC7B77DE}" type="datetimeFigureOut">
               <a:rPr lang="he-IL" smtClean="0"/>
-              <a:t>י'/תשרי/תשפ"ז</a:t>
+              <a:t>י"א/תשרי/תשפ"ז</a:t>
             </a:fld>
             <a:endParaRPr lang="he-IL"/>
           </a:p>
@@ -1157,7 +1154,7 @@
           <a:p>
             <a:fld id="{E23D921C-80E9-4813-9630-6B31BC7B77DE}" type="datetimeFigureOut">
               <a:rPr lang="he-IL" smtClean="0"/>
-              <a:t>י'/תשרי/תשפ"ז</a:t>
+              <a:t>י"א/תשרי/תשפ"ז</a:t>
             </a:fld>
             <a:endParaRPr lang="he-IL"/>
           </a:p>
@@ -1425,7 +1422,7 @@
           <a:p>
             <a:fld id="{E23D921C-80E9-4813-9630-6B31BC7B77DE}" type="datetimeFigureOut">
               <a:rPr lang="he-IL" smtClean="0"/>
-              <a:t>י'/תשרי/תשפ"ז</a:t>
+              <a:t>י"א/תשרי/תשפ"ז</a:t>
             </a:fld>
             <a:endParaRPr lang="he-IL"/>
           </a:p>
@@ -1840,7 +1837,7 @@
           <a:p>
             <a:fld id="{E23D921C-80E9-4813-9630-6B31BC7B77DE}" type="datetimeFigureOut">
               <a:rPr lang="he-IL" smtClean="0"/>
-              <a:t>י'/תשרי/תשפ"ז</a:t>
+              <a:t>י"א/תשרי/תשפ"ז</a:t>
             </a:fld>
             <a:endParaRPr lang="he-IL"/>
           </a:p>
@@ -1982,7 +1979,7 @@
           <a:p>
             <a:fld id="{E23D921C-80E9-4813-9630-6B31BC7B77DE}" type="datetimeFigureOut">
               <a:rPr lang="he-IL" smtClean="0"/>
-              <a:t>י'/תשרי/תשפ"ז</a:t>
+              <a:t>י"א/תשרי/תשפ"ז</a:t>
             </a:fld>
             <a:endParaRPr lang="he-IL"/>
           </a:p>
@@ -2095,7 +2092,7 @@
           <a:p>
             <a:fld id="{E23D921C-80E9-4813-9630-6B31BC7B77DE}" type="datetimeFigureOut">
               <a:rPr lang="he-IL" smtClean="0"/>
-              <a:t>י'/תשרי/תשפ"ז</a:t>
+              <a:t>י"א/תשרי/תשפ"ז</a:t>
             </a:fld>
             <a:endParaRPr lang="he-IL"/>
           </a:p>
@@ -2408,7 +2405,7 @@
           <a:p>
             <a:fld id="{E23D921C-80E9-4813-9630-6B31BC7B77DE}" type="datetimeFigureOut">
               <a:rPr lang="he-IL" smtClean="0"/>
-              <a:t>י'/תשרי/תשפ"ז</a:t>
+              <a:t>י"א/תשרי/תשפ"ז</a:t>
             </a:fld>
             <a:endParaRPr lang="he-IL"/>
           </a:p>
@@ -2697,7 +2694,7 @@
           <a:p>
             <a:fld id="{E23D921C-80E9-4813-9630-6B31BC7B77DE}" type="datetimeFigureOut">
               <a:rPr lang="he-IL" smtClean="0"/>
-              <a:t>י'/תשרי/תשפ"ז</a:t>
+              <a:t>י"א/תשרי/תשפ"ז</a:t>
             </a:fld>
             <a:endParaRPr lang="he-IL"/>
           </a:p>
@@ -2940,7 +2937,7 @@
           <a:p>
             <a:fld id="{E23D921C-80E9-4813-9630-6B31BC7B77DE}" type="datetimeFigureOut">
               <a:rPr lang="he-IL" smtClean="0"/>
-              <a:t>י'/תשרי/תשפ"ז</a:t>
+              <a:t>י"א/תשרי/תשפ"ז</a:t>
             </a:fld>
             <a:endParaRPr lang="he-IL"/>
           </a:p>
@@ -3345,7 +3342,13 @@
   <p:cSld>
     <p:spTree>
       <p:nvGrpSpPr>
-        <p:cNvPr id="1" name=""/>
+        <p:cNvPr id="1" name="">
+          <a:extLst>
+            <a:ext uri="{FF2B5EF4-FFF2-40B4-BE49-F238E27FC236}">
+              <a16:creationId xmlns:a16="http://schemas.microsoft.com/office/drawing/2014/main" id="{C1E411DA-3A6D-3C49-71F9-A2297B949CBA}"/>
+            </a:ext>
+          </a:extLst>
+        </p:cNvPr>
         <p:cNvGrpSpPr/>
         <p:nvPr/>
       </p:nvGrpSpPr>
@@ -3362,7 +3365,7 @@
           <p:cNvPr id="5" name="Picture 4">
             <a:extLst>
               <a:ext uri="{FF2B5EF4-FFF2-40B4-BE49-F238E27FC236}">
-                <a16:creationId xmlns:a16="http://schemas.microsoft.com/office/drawing/2014/main" id="{90AD3BAD-E73B-3E16-8620-7851CB388C7D}"/>
+                <a16:creationId xmlns:a16="http://schemas.microsoft.com/office/drawing/2014/main" id="{3C8475EB-5D48-DE21-8106-B215EA72B6DC}"/>
               </a:ext>
             </a:extLst>
           </p:cNvPr>
@@ -3379,8 +3382,8 @@
         </p:blipFill>
         <p:spPr>
           <a:xfrm>
-            <a:off x="304116" y="267363"/>
-            <a:ext cx="11623419" cy="4555845"/>
+            <a:off x="163235" y="144270"/>
+            <a:ext cx="10378641" cy="6463158"/>
           </a:xfrm>
           <a:prstGeom prst="rect">
             <a:avLst/>
@@ -3390,7 +3393,7 @@
     </p:spTree>
     <p:extLst>
       <p:ext uri="{BB962C8B-B14F-4D97-AF65-F5344CB8AC3E}">
-        <p14:creationId xmlns:p14="http://schemas.microsoft.com/office/powerpoint/2010/main" val="3501518223"/>
+        <p14:creationId xmlns:p14="http://schemas.microsoft.com/office/powerpoint/2010/main" val="3000770512"/>
       </p:ext>
     </p:extLst>
   </p:cSld>
@@ -3400,7 +3403,73 @@
 </p:sld>
 </file>
 
-<file path=ppt/slides/slide10.xml><?xml version="1.0" encoding="utf-8"?>
+<file path=ppt/slides/slide2.xml><?xml version="1.0" encoding="utf-8"?>
+<p:sld xmlns:a="http://schemas.openxmlformats.org/drawingml/2006/main" xmlns:r="http://schemas.openxmlformats.org/officeDocument/2006/relationships" xmlns:p="http://schemas.openxmlformats.org/presentationml/2006/main">
+  <p:cSld>
+    <p:spTree>
+      <p:nvGrpSpPr>
+        <p:cNvPr id="1" name="">
+          <a:extLst>
+            <a:ext uri="{FF2B5EF4-FFF2-40B4-BE49-F238E27FC236}">
+              <a16:creationId xmlns:a16="http://schemas.microsoft.com/office/drawing/2014/main" id="{406EDA05-9A64-9D13-8800-B38D300BF952}"/>
+            </a:ext>
+          </a:extLst>
+        </p:cNvPr>
+        <p:cNvGrpSpPr/>
+        <p:nvPr/>
+      </p:nvGrpSpPr>
+      <p:grpSpPr>
+        <a:xfrm>
+          <a:off x="0" y="0"/>
+          <a:ext cx="0" cy="0"/>
+          <a:chOff x="0" y="0"/>
+          <a:chExt cx="0" cy="0"/>
+        </a:xfrm>
+      </p:grpSpPr>
+      <p:pic>
+        <p:nvPicPr>
+          <p:cNvPr id="3" name="Picture 2">
+            <a:extLst>
+              <a:ext uri="{FF2B5EF4-FFF2-40B4-BE49-F238E27FC236}">
+                <a16:creationId xmlns:a16="http://schemas.microsoft.com/office/drawing/2014/main" id="{BCC8F774-303E-F1CC-EE62-22ABC7DDE3BC}"/>
+              </a:ext>
+            </a:extLst>
+          </p:cNvPr>
+          <p:cNvPicPr>
+            <a:picLocks noChangeAspect="1"/>
+          </p:cNvPicPr>
+          <p:nvPr/>
+        </p:nvPicPr>
+        <p:blipFill>
+          <a:blip r:embed="rId2"/>
+          <a:stretch>
+            <a:fillRect/>
+          </a:stretch>
+        </p:blipFill>
+        <p:spPr>
+          <a:xfrm>
+            <a:off x="282979" y="0"/>
+            <a:ext cx="11884848" cy="6571622"/>
+          </a:xfrm>
+          <a:prstGeom prst="rect">
+            <a:avLst/>
+          </a:prstGeom>
+        </p:spPr>
+      </p:pic>
+    </p:spTree>
+    <p:extLst>
+      <p:ext uri="{BB962C8B-B14F-4D97-AF65-F5344CB8AC3E}">
+        <p14:creationId xmlns:p14="http://schemas.microsoft.com/office/powerpoint/2010/main" val="902846263"/>
+      </p:ext>
+    </p:extLst>
+  </p:cSld>
+  <p:clrMapOvr>
+    <a:masterClrMapping/>
+  </p:clrMapOvr>
+</p:sld>
+</file>
+
+<file path=ppt/slides/slide3.xml><?xml version="1.0" encoding="utf-8"?>
 <p:sld xmlns:a="http://schemas.openxmlformats.org/drawingml/2006/main" xmlns:r="http://schemas.openxmlformats.org/officeDocument/2006/relationships" xmlns:p="http://schemas.openxmlformats.org/presentationml/2006/main">
   <p:cSld>
     <p:spTree>
@@ -3466,7 +3535,187 @@
 </p:sld>
 </file>
 
-<file path=ppt/slides/slide11.xml><?xml version="1.0" encoding="utf-8"?>
+<file path=ppt/slides/slide4.xml><?xml version="1.0" encoding="utf-8"?>
+<p:sld xmlns:a="http://schemas.openxmlformats.org/drawingml/2006/main" xmlns:r="http://schemas.openxmlformats.org/officeDocument/2006/relationships" xmlns:p="http://schemas.openxmlformats.org/presentationml/2006/main">
+  <p:cSld>
+    <p:spTree>
+      <p:nvGrpSpPr>
+        <p:cNvPr id="1" name=""/>
+        <p:cNvGrpSpPr/>
+        <p:nvPr/>
+      </p:nvGrpSpPr>
+      <p:grpSpPr>
+        <a:xfrm>
+          <a:off x="0" y="0"/>
+          <a:ext cx="0" cy="0"/>
+          <a:chOff x="0" y="0"/>
+          <a:chExt cx="0" cy="0"/>
+        </a:xfrm>
+      </p:grpSpPr>
+      <p:pic>
+        <p:nvPicPr>
+          <p:cNvPr id="3" name="Picture 2">
+            <a:extLst>
+              <a:ext uri="{FF2B5EF4-FFF2-40B4-BE49-F238E27FC236}">
+                <a16:creationId xmlns:a16="http://schemas.microsoft.com/office/drawing/2014/main" id="{8793B9D7-6497-F8A9-1DE7-F469F6949A16}"/>
+              </a:ext>
+            </a:extLst>
+          </p:cNvPr>
+          <p:cNvPicPr>
+            <a:picLocks noChangeAspect="1"/>
+          </p:cNvPicPr>
+          <p:nvPr/>
+        </p:nvPicPr>
+        <p:blipFill>
+          <a:blip r:embed="rId2"/>
+          <a:stretch>
+            <a:fillRect/>
+          </a:stretch>
+        </p:blipFill>
+        <p:spPr>
+          <a:xfrm>
+            <a:off x="3016468" y="1056520"/>
+            <a:ext cx="9080758" cy="5060270"/>
+          </a:xfrm>
+          <a:prstGeom prst="rect">
+            <a:avLst/>
+          </a:prstGeom>
+        </p:spPr>
+      </p:pic>
+      <p:pic>
+        <p:nvPicPr>
+          <p:cNvPr id="5" name="Picture 4">
+            <a:extLst>
+              <a:ext uri="{FF2B5EF4-FFF2-40B4-BE49-F238E27FC236}">
+                <a16:creationId xmlns:a16="http://schemas.microsoft.com/office/drawing/2014/main" id="{F8E2DDD2-671F-1D17-C3B2-2851E0DE6886}"/>
+              </a:ext>
+            </a:extLst>
+          </p:cNvPr>
+          <p:cNvPicPr>
+            <a:picLocks noChangeAspect="1"/>
+          </p:cNvPicPr>
+          <p:nvPr/>
+        </p:nvPicPr>
+        <p:blipFill>
+          <a:blip r:embed="rId3"/>
+          <a:stretch>
+            <a:fillRect/>
+          </a:stretch>
+        </p:blipFill>
+        <p:spPr>
+          <a:xfrm>
+            <a:off x="0" y="278524"/>
+            <a:ext cx="3114171" cy="6300952"/>
+          </a:xfrm>
+          <a:prstGeom prst="rect">
+            <a:avLst/>
+          </a:prstGeom>
+        </p:spPr>
+      </p:pic>
+    </p:spTree>
+    <p:extLst>
+      <p:ext uri="{BB962C8B-B14F-4D97-AF65-F5344CB8AC3E}">
+        <p14:creationId xmlns:p14="http://schemas.microsoft.com/office/powerpoint/2010/main" val="2141309638"/>
+      </p:ext>
+    </p:extLst>
+  </p:cSld>
+  <p:clrMapOvr>
+    <a:masterClrMapping/>
+  </p:clrMapOvr>
+</p:sld>
+</file>
+
+<file path=ppt/slides/slide5.xml><?xml version="1.0" encoding="utf-8"?>
+<p:sld xmlns:a="http://schemas.openxmlformats.org/drawingml/2006/main" xmlns:r="http://schemas.openxmlformats.org/officeDocument/2006/relationships" xmlns:p="http://schemas.openxmlformats.org/presentationml/2006/main">
+  <p:cSld>
+    <p:spTree>
+      <p:nvGrpSpPr>
+        <p:cNvPr id="1" name=""/>
+        <p:cNvGrpSpPr/>
+        <p:nvPr/>
+      </p:nvGrpSpPr>
+      <p:grpSpPr>
+        <a:xfrm>
+          <a:off x="0" y="0"/>
+          <a:ext cx="0" cy="0"/>
+          <a:chOff x="0" y="0"/>
+          <a:chExt cx="0" cy="0"/>
+        </a:xfrm>
+      </p:grpSpPr>
+      <p:pic>
+        <p:nvPicPr>
+          <p:cNvPr id="3" name="Picture 2">
+            <a:extLst>
+              <a:ext uri="{FF2B5EF4-FFF2-40B4-BE49-F238E27FC236}">
+                <a16:creationId xmlns:a16="http://schemas.microsoft.com/office/drawing/2014/main" id="{A404698E-9862-0FD7-2F11-1944030783E8}"/>
+              </a:ext>
+            </a:extLst>
+          </p:cNvPr>
+          <p:cNvPicPr>
+            <a:picLocks noChangeAspect="1"/>
+          </p:cNvPicPr>
+          <p:nvPr/>
+        </p:nvPicPr>
+        <p:blipFill>
+          <a:blip r:embed="rId2"/>
+          <a:stretch>
+            <a:fillRect/>
+          </a:stretch>
+        </p:blipFill>
+        <p:spPr>
+          <a:xfrm>
+            <a:off x="3089490" y="958886"/>
+            <a:ext cx="9102510" cy="4940227"/>
+          </a:xfrm>
+          <a:prstGeom prst="rect">
+            <a:avLst/>
+          </a:prstGeom>
+        </p:spPr>
+      </p:pic>
+      <p:pic>
+        <p:nvPicPr>
+          <p:cNvPr id="5" name="Picture 4">
+            <a:extLst>
+              <a:ext uri="{FF2B5EF4-FFF2-40B4-BE49-F238E27FC236}">
+                <a16:creationId xmlns:a16="http://schemas.microsoft.com/office/drawing/2014/main" id="{DFD737DD-26A6-6024-3BB3-D961FACD4BA6}"/>
+              </a:ext>
+            </a:extLst>
+          </p:cNvPr>
+          <p:cNvPicPr>
+            <a:picLocks noChangeAspect="1"/>
+          </p:cNvPicPr>
+          <p:nvPr/>
+        </p:nvPicPr>
+        <p:blipFill>
+          <a:blip r:embed="rId3"/>
+          <a:stretch>
+            <a:fillRect/>
+          </a:stretch>
+        </p:blipFill>
+        <p:spPr>
+          <a:xfrm>
+            <a:off x="0" y="246993"/>
+            <a:ext cx="3145338" cy="6364014"/>
+          </a:xfrm>
+          <a:prstGeom prst="rect">
+            <a:avLst/>
+          </a:prstGeom>
+        </p:spPr>
+      </p:pic>
+    </p:spTree>
+    <p:extLst>
+      <p:ext uri="{BB962C8B-B14F-4D97-AF65-F5344CB8AC3E}">
+        <p14:creationId xmlns:p14="http://schemas.microsoft.com/office/powerpoint/2010/main" val="3633888493"/>
+      </p:ext>
+    </p:extLst>
+  </p:cSld>
+  <p:clrMapOvr>
+    <a:masterClrMapping/>
+  </p:clrMapOvr>
+</p:sld>
+</file>
+
+<file path=ppt/slides/slide6.xml><?xml version="1.0" encoding="utf-8"?>
 <p:sld xmlns:a="http://schemas.openxmlformats.org/drawingml/2006/main" xmlns:r="http://schemas.openxmlformats.org/officeDocument/2006/relationships" xmlns:p="http://schemas.openxmlformats.org/presentationml/2006/main">
   <p:cSld>
     <p:spTree>
@@ -3542,7 +3791,7 @@
         <p:spPr>
           <a:xfrm>
             <a:off x="158673" y="672661"/>
-            <a:ext cx="2570783" cy="5512676"/>
+            <a:ext cx="2784479" cy="5970916"/>
           </a:xfrm>
           <a:prstGeom prst="rect">
             <a:avLst/>
@@ -3562,18 +3811,12 @@
 </p:sld>
 </file>
 
-<file path=ppt/slides/slide2.xml><?xml version="1.0" encoding="utf-8"?>
+<file path=ppt/slides/slide7.xml><?xml version="1.0" encoding="utf-8"?>
 <p:sld xmlns:a="http://schemas.openxmlformats.org/drawingml/2006/main" xmlns:r="http://schemas.openxmlformats.org/officeDocument/2006/relationships" xmlns:p="http://schemas.openxmlformats.org/presentationml/2006/main">
   <p:cSld>
     <p:spTree>
       <p:nvGrpSpPr>
-        <p:cNvPr id="1" name="">
-          <a:extLst>
-            <a:ext uri="{FF2B5EF4-FFF2-40B4-BE49-F238E27FC236}">
-              <a16:creationId xmlns:a16="http://schemas.microsoft.com/office/drawing/2014/main" id="{4FF373A3-3DA5-2F01-8CD9-6605743B7329}"/>
-            </a:ext>
-          </a:extLst>
-        </p:cNvPr>
+        <p:cNvPr id="1" name=""/>
         <p:cNvGrpSpPr/>
         <p:nvPr/>
       </p:nvGrpSpPr>
@@ -3590,7 +3833,7 @@
           <p:cNvPr id="3" name="Picture 2">
             <a:extLst>
               <a:ext uri="{FF2B5EF4-FFF2-40B4-BE49-F238E27FC236}">
-                <a16:creationId xmlns:a16="http://schemas.microsoft.com/office/drawing/2014/main" id="{24C8A831-0D19-C6DA-A79F-1AB16B05EA20}"/>
+                <a16:creationId xmlns:a16="http://schemas.microsoft.com/office/drawing/2014/main" id="{4A3B523E-EE4A-4A23-CA1B-85F073BB6C1B}"/>
               </a:ext>
             </a:extLst>
           </p:cNvPr>
@@ -3607,8 +3850,8 @@
         </p:blipFill>
         <p:spPr>
           <a:xfrm>
-            <a:off x="168705" y="-1"/>
-            <a:ext cx="11595858" cy="5089585"/>
+            <a:off x="381995" y="0"/>
+            <a:ext cx="11428009" cy="6858000"/>
           </a:xfrm>
           <a:prstGeom prst="rect">
             <a:avLst/>
@@ -3618,7 +3861,7 @@
     </p:spTree>
     <p:extLst>
       <p:ext uri="{BB962C8B-B14F-4D97-AF65-F5344CB8AC3E}">
-        <p14:creationId xmlns:p14="http://schemas.microsoft.com/office/powerpoint/2010/main" val="1335894320"/>
+        <p14:creationId xmlns:p14="http://schemas.microsoft.com/office/powerpoint/2010/main" val="3996161116"/>
       </p:ext>
     </p:extLst>
   </p:cSld>
@@ -3628,18 +3871,12 @@
 </p:sld>
 </file>
 
-<file path=ppt/slides/slide3.xml><?xml version="1.0" encoding="utf-8"?>
+<file path=ppt/slides/slide8.xml><?xml version="1.0" encoding="utf-8"?>
 <p:sld xmlns:a="http://schemas.openxmlformats.org/drawingml/2006/main" xmlns:r="http://schemas.openxmlformats.org/officeDocument/2006/relationships" xmlns:p="http://schemas.openxmlformats.org/presentationml/2006/main">
   <p:cSld>
     <p:spTree>
       <p:nvGrpSpPr>
-        <p:cNvPr id="1" name="">
-          <a:extLst>
-            <a:ext uri="{FF2B5EF4-FFF2-40B4-BE49-F238E27FC236}">
-              <a16:creationId xmlns:a16="http://schemas.microsoft.com/office/drawing/2014/main" id="{40EB6718-B263-B973-76FC-F3589CB5F0ED}"/>
-            </a:ext>
-          </a:extLst>
-        </p:cNvPr>
+        <p:cNvPr id="1" name=""/>
         <p:cNvGrpSpPr/>
         <p:nvPr/>
       </p:nvGrpSpPr>
@@ -3656,7 +3893,7 @@
           <p:cNvPr id="3" name="Picture 2">
             <a:extLst>
               <a:ext uri="{FF2B5EF4-FFF2-40B4-BE49-F238E27FC236}">
-                <a16:creationId xmlns:a16="http://schemas.microsoft.com/office/drawing/2014/main" id="{C7D4568E-49A6-090D-36B0-48F69CE880FE}"/>
+                <a16:creationId xmlns:a16="http://schemas.microsoft.com/office/drawing/2014/main" id="{EFEAA49C-18F7-9776-0DF0-6E14344F4F6D}"/>
               </a:ext>
             </a:extLst>
           </p:cNvPr>
@@ -3673,8 +3910,8 @@
         </p:blipFill>
         <p:spPr>
           <a:xfrm>
-            <a:off x="0" y="189186"/>
-            <a:ext cx="8677112" cy="3239814"/>
+            <a:off x="2836662" y="714704"/>
+            <a:ext cx="9355338" cy="5075769"/>
           </a:xfrm>
           <a:prstGeom prst="rect">
             <a:avLst/>
@@ -3686,7 +3923,7 @@
           <p:cNvPr id="5" name="Picture 4">
             <a:extLst>
               <a:ext uri="{FF2B5EF4-FFF2-40B4-BE49-F238E27FC236}">
-                <a16:creationId xmlns:a16="http://schemas.microsoft.com/office/drawing/2014/main" id="{1E7A865E-E85E-A159-B809-8C31BFE5A3CA}"/>
+                <a16:creationId xmlns:a16="http://schemas.microsoft.com/office/drawing/2014/main" id="{6BEFD175-6D44-E494-6B70-0A6B1E263098}"/>
               </a:ext>
             </a:extLst>
           </p:cNvPr>
@@ -3703,8 +3940,8 @@
         </p:blipFill>
         <p:spPr>
           <a:xfrm>
-            <a:off x="2115147" y="3510455"/>
-            <a:ext cx="9952465" cy="3347545"/>
+            <a:off x="0" y="210207"/>
+            <a:ext cx="3169146" cy="6437586"/>
           </a:xfrm>
           <a:prstGeom prst="rect">
             <a:avLst/>
@@ -3714,553 +3951,7 @@
     </p:spTree>
     <p:extLst>
       <p:ext uri="{BB962C8B-B14F-4D97-AF65-F5344CB8AC3E}">
-        <p14:creationId xmlns:p14="http://schemas.microsoft.com/office/powerpoint/2010/main" val="943907904"/>
-      </p:ext>
-    </p:extLst>
-  </p:cSld>
-  <p:clrMapOvr>
-    <a:masterClrMapping/>
-  </p:clrMapOvr>
-</p:sld>
-</file>
-
-<file path=ppt/slides/slide4.xml><?xml version="1.0" encoding="utf-8"?>
-<p:sld xmlns:a="http://schemas.openxmlformats.org/drawingml/2006/main" xmlns:r="http://schemas.openxmlformats.org/officeDocument/2006/relationships" xmlns:p="http://schemas.openxmlformats.org/presentationml/2006/main">
-  <p:cSld>
-    <p:spTree>
-      <p:nvGrpSpPr>
-        <p:cNvPr id="1" name="">
-          <a:extLst>
-            <a:ext uri="{FF2B5EF4-FFF2-40B4-BE49-F238E27FC236}">
-              <a16:creationId xmlns:a16="http://schemas.microsoft.com/office/drawing/2014/main" id="{8A2D66E7-8EDF-9A19-BC24-81818CC27009}"/>
-            </a:ext>
-          </a:extLst>
-        </p:cNvPr>
-        <p:cNvGrpSpPr/>
-        <p:nvPr/>
-      </p:nvGrpSpPr>
-      <p:grpSpPr>
-        <a:xfrm>
-          <a:off x="0" y="0"/>
-          <a:ext cx="0" cy="0"/>
-          <a:chOff x="0" y="0"/>
-          <a:chExt cx="0" cy="0"/>
-        </a:xfrm>
-      </p:grpSpPr>
-      <p:pic>
-        <p:nvPicPr>
-          <p:cNvPr id="3" name="Picture 2">
-            <a:extLst>
-              <a:ext uri="{FF2B5EF4-FFF2-40B4-BE49-F238E27FC236}">
-                <a16:creationId xmlns:a16="http://schemas.microsoft.com/office/drawing/2014/main" id="{7BC1587A-6323-B180-9EE0-4BD61661278B}"/>
-              </a:ext>
-            </a:extLst>
-          </p:cNvPr>
-          <p:cNvPicPr>
-            <a:picLocks noChangeAspect="1"/>
-          </p:cNvPicPr>
-          <p:nvPr/>
-        </p:nvPicPr>
-        <p:blipFill>
-          <a:blip r:embed="rId2"/>
-          <a:stretch>
-            <a:fillRect/>
-          </a:stretch>
-        </p:blipFill>
-        <p:spPr>
-          <a:xfrm>
-            <a:off x="84083" y="201756"/>
-            <a:ext cx="11088414" cy="3596242"/>
-          </a:xfrm>
-          <a:prstGeom prst="rect">
-            <a:avLst/>
-          </a:prstGeom>
-        </p:spPr>
-      </p:pic>
-    </p:spTree>
-    <p:extLst>
-      <p:ext uri="{BB962C8B-B14F-4D97-AF65-F5344CB8AC3E}">
-        <p14:creationId xmlns:p14="http://schemas.microsoft.com/office/powerpoint/2010/main" val="2575212102"/>
-      </p:ext>
-    </p:extLst>
-  </p:cSld>
-  <p:clrMapOvr>
-    <a:masterClrMapping/>
-  </p:clrMapOvr>
-</p:sld>
-</file>
-
-<file path=ppt/slides/slide5.xml><?xml version="1.0" encoding="utf-8"?>
-<p:sld xmlns:a="http://schemas.openxmlformats.org/drawingml/2006/main" xmlns:r="http://schemas.openxmlformats.org/officeDocument/2006/relationships" xmlns:p="http://schemas.openxmlformats.org/presentationml/2006/main">
-  <p:cSld>
-    <p:spTree>
-      <p:nvGrpSpPr>
-        <p:cNvPr id="1" name="">
-          <a:extLst>
-            <a:ext uri="{FF2B5EF4-FFF2-40B4-BE49-F238E27FC236}">
-              <a16:creationId xmlns:a16="http://schemas.microsoft.com/office/drawing/2014/main" id="{C9633D0F-F01A-7E1A-A90B-3353CE06FC32}"/>
-            </a:ext>
-          </a:extLst>
-        </p:cNvPr>
-        <p:cNvGrpSpPr/>
-        <p:nvPr/>
-      </p:nvGrpSpPr>
-      <p:grpSpPr>
-        <a:xfrm>
-          <a:off x="0" y="0"/>
-          <a:ext cx="0" cy="0"/>
-          <a:chOff x="0" y="0"/>
-          <a:chExt cx="0" cy="0"/>
-        </a:xfrm>
-      </p:grpSpPr>
-      <p:pic>
-        <p:nvPicPr>
-          <p:cNvPr id="3" name="Picture 2">
-            <a:extLst>
-              <a:ext uri="{FF2B5EF4-FFF2-40B4-BE49-F238E27FC236}">
-                <a16:creationId xmlns:a16="http://schemas.microsoft.com/office/drawing/2014/main" id="{B355FB77-DA89-0A1C-FD7F-6A9EC653A819}"/>
-              </a:ext>
-            </a:extLst>
-          </p:cNvPr>
-          <p:cNvPicPr>
-            <a:picLocks noChangeAspect="1"/>
-          </p:cNvPicPr>
-          <p:nvPr/>
-        </p:nvPicPr>
-        <p:blipFill>
-          <a:blip r:embed="rId2"/>
-          <a:stretch>
-            <a:fillRect/>
-          </a:stretch>
-        </p:blipFill>
-        <p:spPr>
-          <a:xfrm>
-            <a:off x="94593" y="184850"/>
-            <a:ext cx="12062372" cy="4975729"/>
-          </a:xfrm>
-          <a:prstGeom prst="rect">
-            <a:avLst/>
-          </a:prstGeom>
-        </p:spPr>
-      </p:pic>
-    </p:spTree>
-    <p:extLst>
-      <p:ext uri="{BB962C8B-B14F-4D97-AF65-F5344CB8AC3E}">
-        <p14:creationId xmlns:p14="http://schemas.microsoft.com/office/powerpoint/2010/main" val="2899980821"/>
-      </p:ext>
-    </p:extLst>
-  </p:cSld>
-  <p:clrMapOvr>
-    <a:masterClrMapping/>
-  </p:clrMapOvr>
-</p:sld>
-</file>
-
-<file path=ppt/slides/slide6.xml><?xml version="1.0" encoding="utf-8"?>
-<p:sld xmlns:a="http://schemas.openxmlformats.org/drawingml/2006/main" xmlns:r="http://schemas.openxmlformats.org/officeDocument/2006/relationships" xmlns:p="http://schemas.openxmlformats.org/presentationml/2006/main">
-  <p:cSld>
-    <p:spTree>
-      <p:nvGrpSpPr>
-        <p:cNvPr id="1" name="">
-          <a:extLst>
-            <a:ext uri="{FF2B5EF4-FFF2-40B4-BE49-F238E27FC236}">
-              <a16:creationId xmlns:a16="http://schemas.microsoft.com/office/drawing/2014/main" id="{3FCD4F75-1E6B-5050-CD16-6FC30E565D52}"/>
-            </a:ext>
-          </a:extLst>
-        </p:cNvPr>
-        <p:cNvGrpSpPr/>
-        <p:nvPr/>
-      </p:nvGrpSpPr>
-      <p:grpSpPr>
-        <a:xfrm>
-          <a:off x="0" y="0"/>
-          <a:ext cx="0" cy="0"/>
-          <a:chOff x="0" y="0"/>
-          <a:chExt cx="0" cy="0"/>
-        </a:xfrm>
-      </p:grpSpPr>
-      <p:pic>
-        <p:nvPicPr>
-          <p:cNvPr id="3" name="Picture 2">
-            <a:extLst>
-              <a:ext uri="{FF2B5EF4-FFF2-40B4-BE49-F238E27FC236}">
-                <a16:creationId xmlns:a16="http://schemas.microsoft.com/office/drawing/2014/main" id="{AED94024-7AFB-FE82-8B8C-883B9930CCB5}"/>
-              </a:ext>
-            </a:extLst>
-          </p:cNvPr>
-          <p:cNvPicPr>
-            <a:picLocks noChangeAspect="1"/>
-          </p:cNvPicPr>
-          <p:nvPr/>
-        </p:nvPicPr>
-        <p:blipFill>
-          <a:blip r:embed="rId2"/>
-          <a:stretch>
-            <a:fillRect/>
-          </a:stretch>
-        </p:blipFill>
-        <p:spPr>
-          <a:xfrm>
-            <a:off x="73571" y="256017"/>
-            <a:ext cx="11926317" cy="4852011"/>
-          </a:xfrm>
-          <a:prstGeom prst="rect">
-            <a:avLst/>
-          </a:prstGeom>
-        </p:spPr>
-      </p:pic>
-    </p:spTree>
-    <p:extLst>
-      <p:ext uri="{BB962C8B-B14F-4D97-AF65-F5344CB8AC3E}">
-        <p14:creationId xmlns:p14="http://schemas.microsoft.com/office/powerpoint/2010/main" val="84245233"/>
-      </p:ext>
-    </p:extLst>
-  </p:cSld>
-  <p:clrMapOvr>
-    <a:masterClrMapping/>
-  </p:clrMapOvr>
-</p:sld>
-</file>
-
-<file path=ppt/slides/slide7.xml><?xml version="1.0" encoding="utf-8"?>
-<p:sld xmlns:a="http://schemas.openxmlformats.org/drawingml/2006/main" xmlns:r="http://schemas.openxmlformats.org/officeDocument/2006/relationships" xmlns:p="http://schemas.openxmlformats.org/presentationml/2006/main">
-  <p:cSld>
-    <p:spTree>
-      <p:nvGrpSpPr>
-        <p:cNvPr id="1" name="">
-          <a:extLst>
-            <a:ext uri="{FF2B5EF4-FFF2-40B4-BE49-F238E27FC236}">
-              <a16:creationId xmlns:a16="http://schemas.microsoft.com/office/drawing/2014/main" id="{A46B769C-3E66-B173-2C2A-D843592995FE}"/>
-            </a:ext>
-          </a:extLst>
-        </p:cNvPr>
-        <p:cNvGrpSpPr/>
-        <p:nvPr/>
-      </p:nvGrpSpPr>
-      <p:grpSpPr>
-        <a:xfrm>
-          <a:off x="0" y="0"/>
-          <a:ext cx="0" cy="0"/>
-          <a:chOff x="0" y="0"/>
-          <a:chExt cx="0" cy="0"/>
-        </a:xfrm>
-      </p:grpSpPr>
-      <p:pic>
-        <p:nvPicPr>
-          <p:cNvPr id="3" name="Picture 2">
-            <a:extLst>
-              <a:ext uri="{FF2B5EF4-FFF2-40B4-BE49-F238E27FC236}">
-                <a16:creationId xmlns:a16="http://schemas.microsoft.com/office/drawing/2014/main" id="{6F4E368C-1C23-B086-DD30-2C879017C538}"/>
-              </a:ext>
-            </a:extLst>
-          </p:cNvPr>
-          <p:cNvPicPr>
-            <a:picLocks noChangeAspect="1"/>
-          </p:cNvPicPr>
-          <p:nvPr/>
-        </p:nvPicPr>
-        <p:blipFill>
-          <a:blip r:embed="rId2"/>
-          <a:stretch>
-            <a:fillRect/>
-          </a:stretch>
-        </p:blipFill>
-        <p:spPr>
-          <a:xfrm>
-            <a:off x="73572" y="94593"/>
-            <a:ext cx="5631500" cy="1879531"/>
-          </a:xfrm>
-          <a:prstGeom prst="rect">
-            <a:avLst/>
-          </a:prstGeom>
-        </p:spPr>
-      </p:pic>
-      <p:pic>
-        <p:nvPicPr>
-          <p:cNvPr id="5" name="Picture 4">
-            <a:extLst>
-              <a:ext uri="{FF2B5EF4-FFF2-40B4-BE49-F238E27FC236}">
-                <a16:creationId xmlns:a16="http://schemas.microsoft.com/office/drawing/2014/main" id="{DA2B0AF9-902F-B71D-3F73-4683C2F50A2E}"/>
-              </a:ext>
-            </a:extLst>
-          </p:cNvPr>
-          <p:cNvPicPr>
-            <a:picLocks noChangeAspect="1"/>
-          </p:cNvPicPr>
-          <p:nvPr/>
-        </p:nvPicPr>
-        <p:blipFill>
-          <a:blip r:embed="rId3"/>
-          <a:stretch>
-            <a:fillRect/>
-          </a:stretch>
-        </p:blipFill>
-        <p:spPr>
-          <a:xfrm>
-            <a:off x="73572" y="1974124"/>
-            <a:ext cx="5631500" cy="2160672"/>
-          </a:xfrm>
-          <a:prstGeom prst="rect">
-            <a:avLst/>
-          </a:prstGeom>
-        </p:spPr>
-      </p:pic>
-      <p:pic>
-        <p:nvPicPr>
-          <p:cNvPr id="7" name="Picture 6">
-            <a:extLst>
-              <a:ext uri="{FF2B5EF4-FFF2-40B4-BE49-F238E27FC236}">
-                <a16:creationId xmlns:a16="http://schemas.microsoft.com/office/drawing/2014/main" id="{6558BE1B-F353-1340-8F19-BF62E9EC3806}"/>
-              </a:ext>
-            </a:extLst>
-          </p:cNvPr>
-          <p:cNvPicPr>
-            <a:picLocks noChangeAspect="1"/>
-          </p:cNvPicPr>
-          <p:nvPr/>
-        </p:nvPicPr>
-        <p:blipFill>
-          <a:blip r:embed="rId4"/>
-          <a:stretch>
-            <a:fillRect/>
-          </a:stretch>
-        </p:blipFill>
-        <p:spPr>
-          <a:xfrm>
-            <a:off x="0" y="3930250"/>
-            <a:ext cx="5705072" cy="2124722"/>
-          </a:xfrm>
-          <a:prstGeom prst="rect">
-            <a:avLst/>
-          </a:prstGeom>
-        </p:spPr>
-      </p:pic>
-      <p:pic>
-        <p:nvPicPr>
-          <p:cNvPr id="9" name="Picture 8">
-            <a:extLst>
-              <a:ext uri="{FF2B5EF4-FFF2-40B4-BE49-F238E27FC236}">
-                <a16:creationId xmlns:a16="http://schemas.microsoft.com/office/drawing/2014/main" id="{E962BDDD-15A7-65CE-F289-4B4B563F1949}"/>
-              </a:ext>
-            </a:extLst>
-          </p:cNvPr>
-          <p:cNvPicPr>
-            <a:picLocks noChangeAspect="1"/>
-          </p:cNvPicPr>
-          <p:nvPr/>
-        </p:nvPicPr>
-        <p:blipFill>
-          <a:blip r:embed="rId5"/>
-          <a:stretch>
-            <a:fillRect/>
-          </a:stretch>
-        </p:blipFill>
-        <p:spPr>
-          <a:xfrm>
-            <a:off x="5917324" y="168505"/>
-            <a:ext cx="4635062" cy="1767283"/>
-          </a:xfrm>
-          <a:prstGeom prst="rect">
-            <a:avLst/>
-          </a:prstGeom>
-        </p:spPr>
-      </p:pic>
-      <p:pic>
-        <p:nvPicPr>
-          <p:cNvPr id="13" name="Picture 12">
-            <a:extLst>
-              <a:ext uri="{FF2B5EF4-FFF2-40B4-BE49-F238E27FC236}">
-                <a16:creationId xmlns:a16="http://schemas.microsoft.com/office/drawing/2014/main" id="{4C6D2322-C0FE-6434-621F-438FB90ADBFE}"/>
-              </a:ext>
-            </a:extLst>
-          </p:cNvPr>
-          <p:cNvPicPr>
-            <a:picLocks noChangeAspect="1"/>
-          </p:cNvPicPr>
-          <p:nvPr/>
-        </p:nvPicPr>
-        <p:blipFill>
-          <a:blip r:embed="rId6"/>
-          <a:stretch>
-            <a:fillRect/>
-          </a:stretch>
-        </p:blipFill>
-        <p:spPr>
-          <a:xfrm>
-            <a:off x="5917323" y="2078701"/>
-            <a:ext cx="4635061" cy="1949951"/>
-          </a:xfrm>
-          <a:prstGeom prst="rect">
-            <a:avLst/>
-          </a:prstGeom>
-        </p:spPr>
-      </p:pic>
-      <p:pic>
-        <p:nvPicPr>
-          <p:cNvPr id="15" name="Picture 14">
-            <a:extLst>
-              <a:ext uri="{FF2B5EF4-FFF2-40B4-BE49-F238E27FC236}">
-                <a16:creationId xmlns:a16="http://schemas.microsoft.com/office/drawing/2014/main" id="{532626D2-E691-5DBA-3087-2CA15AB9D5DF}"/>
-              </a:ext>
-            </a:extLst>
-          </p:cNvPr>
-          <p:cNvPicPr>
-            <a:picLocks noChangeAspect="1"/>
-          </p:cNvPicPr>
-          <p:nvPr/>
-        </p:nvPicPr>
-        <p:blipFill>
-          <a:blip r:embed="rId7"/>
-          <a:stretch>
-            <a:fillRect/>
-          </a:stretch>
-        </p:blipFill>
-        <p:spPr>
-          <a:xfrm>
-            <a:off x="5778644" y="4134796"/>
-            <a:ext cx="4635061" cy="2297535"/>
-          </a:xfrm>
-          <a:prstGeom prst="rect">
-            <a:avLst/>
-          </a:prstGeom>
-        </p:spPr>
-      </p:pic>
-    </p:spTree>
-    <p:extLst>
-      <p:ext uri="{BB962C8B-B14F-4D97-AF65-F5344CB8AC3E}">
-        <p14:creationId xmlns:p14="http://schemas.microsoft.com/office/powerpoint/2010/main" val="2863208345"/>
-      </p:ext>
-    </p:extLst>
-  </p:cSld>
-  <p:clrMapOvr>
-    <a:masterClrMapping/>
-  </p:clrMapOvr>
-</p:sld>
-</file>
-
-<file path=ppt/slides/slide8.xml><?xml version="1.0" encoding="utf-8"?>
-<p:sld xmlns:a="http://schemas.openxmlformats.org/drawingml/2006/main" xmlns:r="http://schemas.openxmlformats.org/officeDocument/2006/relationships" xmlns:p="http://schemas.openxmlformats.org/presentationml/2006/main">
-  <p:cSld>
-    <p:spTree>
-      <p:nvGrpSpPr>
-        <p:cNvPr id="1" name="">
-          <a:extLst>
-            <a:ext uri="{FF2B5EF4-FFF2-40B4-BE49-F238E27FC236}">
-              <a16:creationId xmlns:a16="http://schemas.microsoft.com/office/drawing/2014/main" id="{C1E411DA-3A6D-3C49-71F9-A2297B949CBA}"/>
-            </a:ext>
-          </a:extLst>
-        </p:cNvPr>
-        <p:cNvGrpSpPr/>
-        <p:nvPr/>
-      </p:nvGrpSpPr>
-      <p:grpSpPr>
-        <a:xfrm>
-          <a:off x="0" y="0"/>
-          <a:ext cx="0" cy="0"/>
-          <a:chOff x="0" y="0"/>
-          <a:chExt cx="0" cy="0"/>
-        </a:xfrm>
-      </p:grpSpPr>
-      <p:pic>
-        <p:nvPicPr>
-          <p:cNvPr id="5" name="Picture 4">
-            <a:extLst>
-              <a:ext uri="{FF2B5EF4-FFF2-40B4-BE49-F238E27FC236}">
-                <a16:creationId xmlns:a16="http://schemas.microsoft.com/office/drawing/2014/main" id="{3C8475EB-5D48-DE21-8106-B215EA72B6DC}"/>
-              </a:ext>
-            </a:extLst>
-          </p:cNvPr>
-          <p:cNvPicPr>
-            <a:picLocks noChangeAspect="1"/>
-          </p:cNvPicPr>
-          <p:nvPr/>
-        </p:nvPicPr>
-        <p:blipFill>
-          <a:blip r:embed="rId2"/>
-          <a:stretch>
-            <a:fillRect/>
-          </a:stretch>
-        </p:blipFill>
-        <p:spPr>
-          <a:xfrm>
-            <a:off x="163235" y="144270"/>
-            <a:ext cx="10378641" cy="6463158"/>
-          </a:xfrm>
-          <a:prstGeom prst="rect">
-            <a:avLst/>
-          </a:prstGeom>
-        </p:spPr>
-      </p:pic>
-    </p:spTree>
-    <p:extLst>
-      <p:ext uri="{BB962C8B-B14F-4D97-AF65-F5344CB8AC3E}">
-        <p14:creationId xmlns:p14="http://schemas.microsoft.com/office/powerpoint/2010/main" val="3000770512"/>
-      </p:ext>
-    </p:extLst>
-  </p:cSld>
-  <p:clrMapOvr>
-    <a:masterClrMapping/>
-  </p:clrMapOvr>
-</p:sld>
-</file>
-
-<file path=ppt/slides/slide9.xml><?xml version="1.0" encoding="utf-8"?>
-<p:sld xmlns:a="http://schemas.openxmlformats.org/drawingml/2006/main" xmlns:r="http://schemas.openxmlformats.org/officeDocument/2006/relationships" xmlns:p="http://schemas.openxmlformats.org/presentationml/2006/main">
-  <p:cSld>
-    <p:spTree>
-      <p:nvGrpSpPr>
-        <p:cNvPr id="1" name="">
-          <a:extLst>
-            <a:ext uri="{FF2B5EF4-FFF2-40B4-BE49-F238E27FC236}">
-              <a16:creationId xmlns:a16="http://schemas.microsoft.com/office/drawing/2014/main" id="{406EDA05-9A64-9D13-8800-B38D300BF952}"/>
-            </a:ext>
-          </a:extLst>
-        </p:cNvPr>
-        <p:cNvGrpSpPr/>
-        <p:nvPr/>
-      </p:nvGrpSpPr>
-      <p:grpSpPr>
-        <a:xfrm>
-          <a:off x="0" y="0"/>
-          <a:ext cx="0" cy="0"/>
-          <a:chOff x="0" y="0"/>
-          <a:chExt cx="0" cy="0"/>
-        </a:xfrm>
-      </p:grpSpPr>
-      <p:pic>
-        <p:nvPicPr>
-          <p:cNvPr id="3" name="Picture 2">
-            <a:extLst>
-              <a:ext uri="{FF2B5EF4-FFF2-40B4-BE49-F238E27FC236}">
-                <a16:creationId xmlns:a16="http://schemas.microsoft.com/office/drawing/2014/main" id="{BCC8F774-303E-F1CC-EE62-22ABC7DDE3BC}"/>
-              </a:ext>
-            </a:extLst>
-          </p:cNvPr>
-          <p:cNvPicPr>
-            <a:picLocks noChangeAspect="1"/>
-          </p:cNvPicPr>
-          <p:nvPr/>
-        </p:nvPicPr>
-        <p:blipFill>
-          <a:blip r:embed="rId2"/>
-          <a:stretch>
-            <a:fillRect/>
-          </a:stretch>
-        </p:blipFill>
-        <p:spPr>
-          <a:xfrm>
-            <a:off x="282979" y="0"/>
-            <a:ext cx="11884848" cy="6571622"/>
-          </a:xfrm>
-          <a:prstGeom prst="rect">
-            <a:avLst/>
-          </a:prstGeom>
-        </p:spPr>
-      </p:pic>
-    </p:spTree>
-    <p:extLst>
-      <p:ext uri="{BB962C8B-B14F-4D97-AF65-F5344CB8AC3E}">
-        <p14:creationId xmlns:p14="http://schemas.microsoft.com/office/powerpoint/2010/main" val="902846263"/>
+        <p14:creationId xmlns:p14="http://schemas.microsoft.com/office/powerpoint/2010/main" val="3116877480"/>
       </p:ext>
     </p:extLst>
   </p:cSld>

</xml_diff>

<commit_message>
Update ConfigExamples presentation file
</commit_message>
<xml_diff>
--- a/ConfigExamples.pptx
+++ b/ConfigExamples.pptx
@@ -3612,6 +3612,81 @@
           </a:prstGeom>
         </p:spPr>
       </p:pic>
+      <p:cxnSp>
+        <p:nvCxnSpPr>
+          <p:cNvPr id="4" name="Straight Arrow Connector 3">
+            <a:extLst>
+              <a:ext uri="{FF2B5EF4-FFF2-40B4-BE49-F238E27FC236}">
+                <a16:creationId xmlns:a16="http://schemas.microsoft.com/office/drawing/2014/main" id="{6EF8FDD0-ADEC-EBF3-E6A9-AF708F51CE2A}"/>
+              </a:ext>
+            </a:extLst>
+          </p:cNvPr>
+          <p:cNvCxnSpPr/>
+          <p:nvPr/>
+        </p:nvCxnSpPr>
+        <p:spPr>
+          <a:xfrm>
+            <a:off x="10282687" y="491706"/>
+            <a:ext cx="1268083" cy="0"/>
+          </a:xfrm>
+          <a:prstGeom prst="straightConnector1">
+            <a:avLst/>
+          </a:prstGeom>
+          <a:ln>
+            <a:tailEnd type="triangle"/>
+          </a:ln>
+        </p:spPr>
+        <p:style>
+          <a:lnRef idx="2">
+            <a:schemeClr val="accent1"/>
+          </a:lnRef>
+          <a:fillRef idx="0">
+            <a:schemeClr val="accent1"/>
+          </a:fillRef>
+          <a:effectRef idx="1">
+            <a:schemeClr val="accent1"/>
+          </a:effectRef>
+          <a:fontRef idx="minor">
+            <a:schemeClr val="tx1"/>
+          </a:fontRef>
+        </p:style>
+      </p:cxnSp>
+      <p:sp>
+        <p:nvSpPr>
+          <p:cNvPr id="6" name="TextBox 5">
+            <a:extLst>
+              <a:ext uri="{FF2B5EF4-FFF2-40B4-BE49-F238E27FC236}">
+                <a16:creationId xmlns:a16="http://schemas.microsoft.com/office/drawing/2014/main" id="{D2E8C3B2-A8F4-7DAD-2608-C602859DDCF1}"/>
+              </a:ext>
+            </a:extLst>
+          </p:cNvPr>
+          <p:cNvSpPr txBox="1"/>
+          <p:nvPr/>
+        </p:nvSpPr>
+        <p:spPr>
+          <a:xfrm>
+            <a:off x="10557495" y="122374"/>
+            <a:ext cx="718466" cy="369332"/>
+          </a:xfrm>
+          <a:prstGeom prst="rect">
+            <a:avLst/>
+          </a:prstGeom>
+          <a:noFill/>
+        </p:spPr>
+        <p:txBody>
+          <a:bodyPr wrap="none" rtlCol="1">
+            <a:spAutoFit/>
+          </a:bodyPr>
+          <a:lstStyle/>
+          <a:p>
+            <a:r>
+              <a:rPr lang="en-US" dirty="0"/>
+              <a:t>0 deg</a:t>
+            </a:r>
+            <a:endParaRPr lang="he-IL" dirty="0"/>
+          </a:p>
+        </p:txBody>
+      </p:sp>
     </p:spTree>
     <p:extLst>
       <p:ext uri="{BB962C8B-B14F-4D97-AF65-F5344CB8AC3E}">
@@ -3664,7 +3739,7 @@
         </p:blipFill>
         <p:spPr>
           <a:xfrm>
-            <a:off x="3089490" y="958886"/>
+            <a:off x="3089490" y="0"/>
             <a:ext cx="9102510" cy="4940227"/>
           </a:xfrm>
           <a:prstGeom prst="rect">
@@ -3696,6 +3771,111 @@
           <a:xfrm>
             <a:off x="0" y="246993"/>
             <a:ext cx="3145338" cy="6364014"/>
+          </a:xfrm>
+          <a:prstGeom prst="rect">
+            <a:avLst/>
+          </a:prstGeom>
+        </p:spPr>
+      </p:pic>
+      <p:cxnSp>
+        <p:nvCxnSpPr>
+          <p:cNvPr id="2" name="Straight Arrow Connector 1">
+            <a:extLst>
+              <a:ext uri="{FF2B5EF4-FFF2-40B4-BE49-F238E27FC236}">
+                <a16:creationId xmlns:a16="http://schemas.microsoft.com/office/drawing/2014/main" id="{9CFB3855-9912-D4B7-B6EF-E9C630F116ED}"/>
+              </a:ext>
+            </a:extLst>
+          </p:cNvPr>
+          <p:cNvCxnSpPr/>
+          <p:nvPr/>
+        </p:nvCxnSpPr>
+        <p:spPr>
+          <a:xfrm>
+            <a:off x="10282687" y="491706"/>
+            <a:ext cx="1268083" cy="0"/>
+          </a:xfrm>
+          <a:prstGeom prst="straightConnector1">
+            <a:avLst/>
+          </a:prstGeom>
+          <a:ln>
+            <a:tailEnd type="triangle"/>
+          </a:ln>
+        </p:spPr>
+        <p:style>
+          <a:lnRef idx="2">
+            <a:schemeClr val="accent1"/>
+          </a:lnRef>
+          <a:fillRef idx="0">
+            <a:schemeClr val="accent1"/>
+          </a:fillRef>
+          <a:effectRef idx="1">
+            <a:schemeClr val="accent1"/>
+          </a:effectRef>
+          <a:fontRef idx="minor">
+            <a:schemeClr val="tx1"/>
+          </a:fontRef>
+        </p:style>
+      </p:cxnSp>
+      <p:sp>
+        <p:nvSpPr>
+          <p:cNvPr id="4" name="TextBox 3">
+            <a:extLst>
+              <a:ext uri="{FF2B5EF4-FFF2-40B4-BE49-F238E27FC236}">
+                <a16:creationId xmlns:a16="http://schemas.microsoft.com/office/drawing/2014/main" id="{07991EFB-850C-28E9-B6D1-03DAFCBFC0F4}"/>
+              </a:ext>
+            </a:extLst>
+          </p:cNvPr>
+          <p:cNvSpPr txBox="1"/>
+          <p:nvPr/>
+        </p:nvSpPr>
+        <p:spPr>
+          <a:xfrm>
+            <a:off x="10557495" y="122374"/>
+            <a:ext cx="718466" cy="369332"/>
+          </a:xfrm>
+          <a:prstGeom prst="rect">
+            <a:avLst/>
+          </a:prstGeom>
+          <a:noFill/>
+        </p:spPr>
+        <p:txBody>
+          <a:bodyPr wrap="none" rtlCol="1">
+            <a:spAutoFit/>
+          </a:bodyPr>
+          <a:lstStyle/>
+          <a:p>
+            <a:r>
+              <a:rPr lang="en-US" dirty="0"/>
+              <a:t>0 deg</a:t>
+            </a:r>
+            <a:endParaRPr lang="he-IL" dirty="0"/>
+          </a:p>
+        </p:txBody>
+      </p:sp>
+      <p:pic>
+        <p:nvPicPr>
+          <p:cNvPr id="7" name="Picture 6">
+            <a:extLst>
+              <a:ext uri="{FF2B5EF4-FFF2-40B4-BE49-F238E27FC236}">
+                <a16:creationId xmlns:a16="http://schemas.microsoft.com/office/drawing/2014/main" id="{2D3B0BDA-08FD-460F-886F-6A4E322F737E}"/>
+              </a:ext>
+            </a:extLst>
+          </p:cNvPr>
+          <p:cNvPicPr>
+            <a:picLocks noChangeAspect="1"/>
+          </p:cNvPicPr>
+          <p:nvPr/>
+        </p:nvPicPr>
+        <p:blipFill>
+          <a:blip r:embed="rId4"/>
+          <a:stretch>
+            <a:fillRect/>
+          </a:stretch>
+        </p:blipFill>
+        <p:spPr>
+          <a:xfrm>
+            <a:off x="6763174" y="4829183"/>
+            <a:ext cx="2360616" cy="2028817"/>
           </a:xfrm>
           <a:prstGeom prst="rect">
             <a:avLst/>
@@ -3798,6 +3978,81 @@
           </a:prstGeom>
         </p:spPr>
       </p:pic>
+      <p:cxnSp>
+        <p:nvCxnSpPr>
+          <p:cNvPr id="2" name="Straight Arrow Connector 1">
+            <a:extLst>
+              <a:ext uri="{FF2B5EF4-FFF2-40B4-BE49-F238E27FC236}">
+                <a16:creationId xmlns:a16="http://schemas.microsoft.com/office/drawing/2014/main" id="{4F5AA2B3-6239-9CB6-15F2-EFD5DDB08AB5}"/>
+              </a:ext>
+            </a:extLst>
+          </p:cNvPr>
+          <p:cNvCxnSpPr/>
+          <p:nvPr/>
+        </p:nvCxnSpPr>
+        <p:spPr>
+          <a:xfrm>
+            <a:off x="10282687" y="491706"/>
+            <a:ext cx="1268083" cy="0"/>
+          </a:xfrm>
+          <a:prstGeom prst="straightConnector1">
+            <a:avLst/>
+          </a:prstGeom>
+          <a:ln>
+            <a:tailEnd type="triangle"/>
+          </a:ln>
+        </p:spPr>
+        <p:style>
+          <a:lnRef idx="2">
+            <a:schemeClr val="accent1"/>
+          </a:lnRef>
+          <a:fillRef idx="0">
+            <a:schemeClr val="accent1"/>
+          </a:fillRef>
+          <a:effectRef idx="1">
+            <a:schemeClr val="accent1"/>
+          </a:effectRef>
+          <a:fontRef idx="minor">
+            <a:schemeClr val="tx1"/>
+          </a:fontRef>
+        </p:style>
+      </p:cxnSp>
+      <p:sp>
+        <p:nvSpPr>
+          <p:cNvPr id="4" name="TextBox 3">
+            <a:extLst>
+              <a:ext uri="{FF2B5EF4-FFF2-40B4-BE49-F238E27FC236}">
+                <a16:creationId xmlns:a16="http://schemas.microsoft.com/office/drawing/2014/main" id="{C37F26B4-3FC5-FB5E-164D-6285A7B9263C}"/>
+              </a:ext>
+            </a:extLst>
+          </p:cNvPr>
+          <p:cNvSpPr txBox="1"/>
+          <p:nvPr/>
+        </p:nvSpPr>
+        <p:spPr>
+          <a:xfrm>
+            <a:off x="10557495" y="122374"/>
+            <a:ext cx="718466" cy="369332"/>
+          </a:xfrm>
+          <a:prstGeom prst="rect">
+            <a:avLst/>
+          </a:prstGeom>
+          <a:noFill/>
+        </p:spPr>
+        <p:txBody>
+          <a:bodyPr wrap="none" rtlCol="1">
+            <a:spAutoFit/>
+          </a:bodyPr>
+          <a:lstStyle/>
+          <a:p>
+            <a:r>
+              <a:rPr lang="en-US" dirty="0"/>
+              <a:t>0 deg</a:t>
+            </a:r>
+            <a:endParaRPr lang="he-IL" dirty="0"/>
+          </a:p>
+        </p:txBody>
+      </p:sp>
     </p:spTree>
     <p:extLst>
       <p:ext uri="{BB962C8B-B14F-4D97-AF65-F5344CB8AC3E}">
@@ -3858,6 +4113,81 @@
           </a:prstGeom>
         </p:spPr>
       </p:pic>
+      <p:cxnSp>
+        <p:nvCxnSpPr>
+          <p:cNvPr id="2" name="Straight Arrow Connector 1">
+            <a:extLst>
+              <a:ext uri="{FF2B5EF4-FFF2-40B4-BE49-F238E27FC236}">
+                <a16:creationId xmlns:a16="http://schemas.microsoft.com/office/drawing/2014/main" id="{B5FA2517-6181-EEEC-5BE0-9CBEDA266DCA}"/>
+              </a:ext>
+            </a:extLst>
+          </p:cNvPr>
+          <p:cNvCxnSpPr/>
+          <p:nvPr/>
+        </p:nvCxnSpPr>
+        <p:spPr>
+          <a:xfrm>
+            <a:off x="10274061" y="2087592"/>
+            <a:ext cx="1268083" cy="0"/>
+          </a:xfrm>
+          <a:prstGeom prst="straightConnector1">
+            <a:avLst/>
+          </a:prstGeom>
+          <a:ln>
+            <a:tailEnd type="triangle"/>
+          </a:ln>
+        </p:spPr>
+        <p:style>
+          <a:lnRef idx="2">
+            <a:schemeClr val="accent1"/>
+          </a:lnRef>
+          <a:fillRef idx="0">
+            <a:schemeClr val="accent1"/>
+          </a:fillRef>
+          <a:effectRef idx="1">
+            <a:schemeClr val="accent1"/>
+          </a:effectRef>
+          <a:fontRef idx="minor">
+            <a:schemeClr val="tx1"/>
+          </a:fontRef>
+        </p:style>
+      </p:cxnSp>
+      <p:sp>
+        <p:nvSpPr>
+          <p:cNvPr id="4" name="TextBox 3">
+            <a:extLst>
+              <a:ext uri="{FF2B5EF4-FFF2-40B4-BE49-F238E27FC236}">
+                <a16:creationId xmlns:a16="http://schemas.microsoft.com/office/drawing/2014/main" id="{22BD548F-364D-6371-FE32-C78388B7FE8C}"/>
+              </a:ext>
+            </a:extLst>
+          </p:cNvPr>
+          <p:cNvSpPr txBox="1"/>
+          <p:nvPr/>
+        </p:nvSpPr>
+        <p:spPr>
+          <a:xfrm>
+            <a:off x="10548869" y="1718260"/>
+            <a:ext cx="718466" cy="369332"/>
+          </a:xfrm>
+          <a:prstGeom prst="rect">
+            <a:avLst/>
+          </a:prstGeom>
+          <a:noFill/>
+        </p:spPr>
+        <p:txBody>
+          <a:bodyPr wrap="none" rtlCol="1">
+            <a:spAutoFit/>
+          </a:bodyPr>
+          <a:lstStyle/>
+          <a:p>
+            <a:r>
+              <a:rPr lang="en-US" dirty="0"/>
+              <a:t>0 deg</a:t>
+            </a:r>
+            <a:endParaRPr lang="he-IL" dirty="0"/>
+          </a:p>
+        </p:txBody>
+      </p:sp>
     </p:spTree>
     <p:extLst>
       <p:ext uri="{BB962C8B-B14F-4D97-AF65-F5344CB8AC3E}">

</xml_diff>